<commit_message>
Centre cycle arrowheads on the ring
The ring band was drawn inside the radius the nodes and arrows sit on,
leaving arrows 0.035" outside its centreline. The band now straddles
that radius, and each arrowhead is nudged forward so its centroid, not
its bounding box, sits midway between nodes. Rebuilt the demo decks.

Co-Authored-By: Claude Opus 5.5 <noreply@anthropic.com>
</commit_message>
<xml_diff>
--- a/out/demo_advanced.pptx
+++ b/out/demo_advanced.pptx
@@ -12811,12 +12811,12 @@
         </p:nvSpPr>
         <p:spPr>
           <a:xfrm>
-            <a:off x="2658241" y="2720340"/>
-            <a:ext cx="2286000" cy="2286000"/>
+            <a:off x="2626237" y="2688336"/>
+            <a:ext cx="2350008" cy="2350008"/>
           </a:xfrm>
           <a:prstGeom prst="donut">
             <a:avLst>
-              <a:gd name="adj" fmla="val 2799"/>
+              <a:gd name="adj" fmla="val 2723"/>
             </a:avLst>
           </a:prstGeom>
           <a:solidFill>
@@ -12857,7 +12857,7 @@
         </p:nvSpPr>
         <p:spPr>
           <a:xfrm rot="7200000">
-            <a:off x="4263013" y="2782032"/>
+            <a:off x="4289409" y="2797272"/>
             <a:ext cx="219456" cy="182880"/>
           </a:xfrm>
           <a:prstGeom prst="triangle">
@@ -12901,7 +12901,7 @@
         </p:nvSpPr>
         <p:spPr>
           <a:xfrm rot="10800000">
-            <a:off x="4834513" y="3771900"/>
+            <a:off x="4834513" y="3802380"/>
             <a:ext cx="219456" cy="182880"/>
           </a:xfrm>
           <a:prstGeom prst="triangle">
@@ -12945,7 +12945,7 @@
         </p:nvSpPr>
         <p:spPr>
           <a:xfrm rot="14400000">
-            <a:off x="4263013" y="4761767"/>
+            <a:off x="4236617" y="4777007"/>
             <a:ext cx="219456" cy="182880"/>
           </a:xfrm>
           <a:prstGeom prst="triangle">
@@ -12989,7 +12989,7 @@
         </p:nvSpPr>
         <p:spPr>
           <a:xfrm rot="18000000">
-            <a:off x="3120013" y="4761767"/>
+            <a:off x="3093617" y="4746527"/>
             <a:ext cx="219456" cy="182880"/>
           </a:xfrm>
           <a:prstGeom prst="triangle">
@@ -13033,7 +13033,7 @@
         </p:nvSpPr>
         <p:spPr>
           <a:xfrm rot="0">
-            <a:off x="2548513" y="3771900"/>
+            <a:off x="2548513" y="3741420"/>
             <a:ext cx="219456" cy="182880"/>
           </a:xfrm>
           <a:prstGeom prst="triangle">
@@ -13077,7 +13077,7 @@
         </p:nvSpPr>
         <p:spPr>
           <a:xfrm rot="3600000">
-            <a:off x="3120013" y="2782032"/>
+            <a:off x="3146409" y="2766792"/>
             <a:ext cx="219456" cy="182880"/>
           </a:xfrm>
           <a:prstGeom prst="triangle">

</xml_diff>

<commit_message>
Darken cycle arrowheads so they stand out from the ring
The arrowheads were a tint of the same grey as the ring and read as
bumps on the line. They now use the theme's muted colour. Rebuilt the
demo decks.

Co-Authored-By: Claude Opus 5.5 <noreply@anthropic.com>
</commit_message>
<xml_diff>
--- a/out/demo_advanced.pptx
+++ b/out/demo_advanced.pptx
@@ -12864,7 +12864,7 @@
             <a:avLst/>
           </a:prstGeom>
           <a:solidFill>
-            <a:srgbClr val="CDD6E1"/>
+            <a:srgbClr val="5C6B7A"/>
           </a:solidFill>
           <a:ln>
             <a:noFill/>
@@ -12908,7 +12908,7 @@
             <a:avLst/>
           </a:prstGeom>
           <a:solidFill>
-            <a:srgbClr val="CDD6E1"/>
+            <a:srgbClr val="5C6B7A"/>
           </a:solidFill>
           <a:ln>
             <a:noFill/>
@@ -12952,7 +12952,7 @@
             <a:avLst/>
           </a:prstGeom>
           <a:solidFill>
-            <a:srgbClr val="CDD6E1"/>
+            <a:srgbClr val="5C6B7A"/>
           </a:solidFill>
           <a:ln>
             <a:noFill/>
@@ -12996,7 +12996,7 @@
             <a:avLst/>
           </a:prstGeom>
           <a:solidFill>
-            <a:srgbClr val="CDD6E1"/>
+            <a:srgbClr val="5C6B7A"/>
           </a:solidFill>
           <a:ln>
             <a:noFill/>
@@ -13040,7 +13040,7 @@
             <a:avLst/>
           </a:prstGeom>
           <a:solidFill>
-            <a:srgbClr val="CDD6E1"/>
+            <a:srgbClr val="5C6B7A"/>
           </a:solidFill>
           <a:ln>
             <a:noFill/>
@@ -13084,7 +13084,7 @@
             <a:avLst/>
           </a:prstGeom>
           <a:solidFill>
-            <a:srgbClr val="CDD6E1"/>
+            <a:srgbClr val="5C6B7A"/>
           </a:solidFill>
           <a:ln>
             <a:noFill/>

</xml_diff>